<commit_message>
feat: implement email notification and update slideshow functionality
</commit_message>
<xml_diff>
--- a/disciplinary final slides.pptx
+++ b/disciplinary final slides.pptx
@@ -16,23 +16,24 @@
     <p:sldId id="261" r:id="rId11"/>
     <p:sldId id="262" r:id="rId12"/>
     <p:sldId id="263" r:id="rId13"/>
+    <p:sldId id="264" r:id="rId14"/>
   </p:sldIdLst>
   <p:sldSz cy="5143500" cx="9144000"/>
   <p:notesSz cx="6858000" cy="9144000"/>
   <p:embeddedFontLst>
     <p:embeddedFont>
       <p:font typeface="Raleway"/>
-      <p:regular r:id="rId14"/>
-      <p:bold r:id="rId15"/>
-      <p:italic r:id="rId16"/>
-      <p:boldItalic r:id="rId17"/>
+      <p:regular r:id="rId15"/>
+      <p:bold r:id="rId16"/>
+      <p:italic r:id="rId17"/>
+      <p:boldItalic r:id="rId18"/>
     </p:embeddedFont>
     <p:embeddedFont>
       <p:font typeface="Lato"/>
-      <p:regular r:id="rId18"/>
-      <p:bold r:id="rId19"/>
-      <p:italic r:id="rId20"/>
-      <p:boldItalic r:id="rId21"/>
+      <p:regular r:id="rId19"/>
+      <p:bold r:id="rId20"/>
+      <p:italic r:id="rId21"/>
+      <p:boldItalic r:id="rId22"/>
     </p:embeddedFont>
   </p:embeddedFontLst>
   <p:defaultTextStyle>
@@ -1681,6 +1682,105 @@
                 <a:sym typeface="Times New Roman"/>
               </a:rPr>
               <a:t>The examination through multiple academic disciplines of the 9/11 attacks demonstrates the significance of the attacks and how it extends beyond just the events of that day. American culture was fundamentally reshaped by the attacks and continues to influence society more than two decades later. From a historical perspective, 9/11 transformed how the United States approached national security, terrorism, surveillance, and military interventions. The policies that were enacted in response to the attack continue to affect governmental authority and public life. The means to help process the grief, trauma, and uncertainty was provided by literature, while allowing for the exploration of questions related to identity and cultural conflict. The emotional impact of the attacks are difficult to capture and preserve with only historical records, novels were able to capture these impacts for future generations. The attacks revealed how a major event can change the perceptions of a religious community. Islam was pushed to the forefront of discussions on religion, extremist fundamentalism, and the relationship religion has with violence. Society was encouraged through philosophy to examine difficult questions concerning liberty, security, ethics of war, and justice. Public policy and discussions continue to be influenced by these debates. Society’s evolving understanding of terrorism and the War on Terror is reflected by the fine arts. The tragedy, uncertainty, and complexity of the attacks and the following years was captured by the artistic responses. When the 9/11 attacks are viewed collectively through these disciplines it is clear that it was not simply a terrorist attack. It was a turning point in American culture that altered how Americans view and think about national security, identity, religion, morality, and memory. Understanding the attacks through the interdisciplinary impacts helps to explain the legacy of 9/11 and how it continues to influence American society today.</a:t>
+            </a:r>
+            <a:endParaRPr/>
+          </a:p>
+        </p:txBody>
+      </p:sp>
+    </p:spTree>
+  </p:cSld>
+  <p:clrMapOvr>
+    <a:masterClrMapping/>
+  </p:clrMapOvr>
+</p:notes>
+</file>
+
+<file path=ppt/notesSlides/notesSlide9.xml><?xml version="1.0" encoding="utf-8"?>
+<p:notes xmlns:a="http://schemas.openxmlformats.org/drawingml/2006/main" xmlns:r="http://schemas.openxmlformats.org/officeDocument/2006/relationships" xmlns:mc="http://schemas.openxmlformats.org/markup-compatibility/2006" xmlns:mv="urn:schemas-microsoft-com:mac:vml" xmlns:p="http://schemas.openxmlformats.org/presentationml/2006/main" xmlns:c="http://schemas.openxmlformats.org/drawingml/2006/chart" xmlns:dgm="http://schemas.openxmlformats.org/drawingml/2006/diagram" xmlns:o="urn:schemas-microsoft-com:office:office" xmlns:v="urn:schemas-microsoft-com:vml" xmlns:pvml="urn:schemas-microsoft-com:office:powerpoint" xmlns:com="http://schemas.openxmlformats.org/drawingml/2006/compatibility" xmlns:p14="http://schemas.microsoft.com/office/powerpoint/2010/main" xmlns:p15="http://schemas.microsoft.com/office/powerpoint/2012/main" xmlns:ahyp="http://schemas.microsoft.com/office/drawing/2018/hyperlinkcolor" showMasterPhAnim="0" showMasterSp="0">
+  <p:cSld>
+    <p:spTree>
+      <p:nvGrpSpPr>
+        <p:cNvPr id="131" name="Shape 131"/>
+        <p:cNvGrpSpPr/>
+        <p:nvPr/>
+      </p:nvGrpSpPr>
+      <p:grpSpPr>
+        <a:xfrm>
+          <a:off x="0" y="0"/>
+          <a:ext cx="0" cy="0"/>
+          <a:chOff x="0" y="0"/>
+          <a:chExt cx="0" cy="0"/>
+        </a:xfrm>
+      </p:grpSpPr>
+      <p:sp>
+        <p:nvSpPr>
+          <p:cNvPr id="132" name="Google Shape;132;g3edd4a4b7fb_0_0:notes"/>
+          <p:cNvSpPr/>
+          <p:nvPr>
+            <p:ph idx="2" type="sldImg"/>
+          </p:nvPr>
+        </p:nvSpPr>
+        <p:spPr>
+          <a:xfrm>
+            <a:off x="381300" y="685800"/>
+            <a:ext cx="6096000" cy="3429000"/>
+          </a:xfrm>
+          <a:custGeom>
+            <a:rect b="b" l="l" r="r" t="t"/>
+            <a:pathLst>
+              <a:path extrusionOk="0" h="120000" w="120000">
+                <a:moveTo>
+                  <a:pt x="0" y="0"/>
+                </a:moveTo>
+                <a:lnTo>
+                  <a:pt x="120000" y="0"/>
+                </a:lnTo>
+                <a:lnTo>
+                  <a:pt x="120000" y="120000"/>
+                </a:lnTo>
+                <a:lnTo>
+                  <a:pt x="0" y="120000"/>
+                </a:lnTo>
+                <a:close/>
+              </a:path>
+            </a:pathLst>
+          </a:custGeom>
+        </p:spPr>
+      </p:sp>
+      <p:sp>
+        <p:nvSpPr>
+          <p:cNvPr id="133" name="Google Shape;133;g3edd4a4b7fb_0_0:notes"/>
+          <p:cNvSpPr txBox="1"/>
+          <p:nvPr>
+            <p:ph idx="1" type="body"/>
+          </p:nvPr>
+        </p:nvSpPr>
+        <p:spPr>
+          <a:xfrm>
+            <a:off x="685800" y="4343400"/>
+            <a:ext cx="5486400" cy="4114800"/>
+          </a:xfrm>
+          <a:prstGeom prst="rect">
+            <a:avLst/>
+          </a:prstGeom>
+        </p:spPr>
+        <p:txBody>
+          <a:bodyPr anchorCtr="0" anchor="t" bIns="91425" lIns="91425" spcFirstLastPara="1" rIns="91425" wrap="square" tIns="91425">
+            <a:noAutofit/>
+          </a:bodyPr>
+          <a:lstStyle/>
+          <a:p>
+            <a:pPr indent="0" lvl="0" marL="0" rtl="0" algn="l">
+              <a:spcBef>
+                <a:spcPts val="0"/>
+              </a:spcBef>
+              <a:spcAft>
+                <a:spcPts val="0"/>
+              </a:spcAft>
+              <a:buNone/>
+            </a:pPr>
+            <a:r>
+              <a:t/>
             </a:r>
             <a:endParaRPr/>
           </a:p>
@@ -10400,7 +10500,701 @@
 </p:sld>
 </file>
 
+<file path=ppt/slides/slide9.xml><?xml version="1.0" encoding="utf-8"?>
+<p:sld xmlns:a="http://schemas.openxmlformats.org/drawingml/2006/main" xmlns:r="http://schemas.openxmlformats.org/officeDocument/2006/relationships" xmlns:mc="http://schemas.openxmlformats.org/markup-compatibility/2006" xmlns:mv="urn:schemas-microsoft-com:mac:vml" xmlns:p="http://schemas.openxmlformats.org/presentationml/2006/main" xmlns:c="http://schemas.openxmlformats.org/drawingml/2006/chart" xmlns:dgm="http://schemas.openxmlformats.org/drawingml/2006/diagram" xmlns:o="urn:schemas-microsoft-com:office:office" xmlns:v="urn:schemas-microsoft-com:vml" xmlns:pvml="urn:schemas-microsoft-com:office:powerpoint" xmlns:com="http://schemas.openxmlformats.org/drawingml/2006/compatibility" xmlns:p14="http://schemas.microsoft.com/office/powerpoint/2010/main" xmlns:p15="http://schemas.microsoft.com/office/powerpoint/2012/main" xmlns:ahyp="http://schemas.microsoft.com/office/drawing/2018/hyperlinkcolor">
+  <p:cSld>
+    <p:spTree>
+      <p:nvGrpSpPr>
+        <p:cNvPr id="134" name="Shape 134"/>
+        <p:cNvGrpSpPr/>
+        <p:nvPr/>
+      </p:nvGrpSpPr>
+      <p:grpSpPr>
+        <a:xfrm>
+          <a:off x="0" y="0"/>
+          <a:ext cx="0" cy="0"/>
+          <a:chOff x="0" y="0"/>
+          <a:chExt cx="0" cy="0"/>
+        </a:xfrm>
+      </p:grpSpPr>
+      <p:sp>
+        <p:nvSpPr>
+          <p:cNvPr id="135" name="Google Shape;135;p21"/>
+          <p:cNvSpPr txBox="1"/>
+          <p:nvPr>
+            <p:ph type="title"/>
+          </p:nvPr>
+        </p:nvSpPr>
+        <p:spPr>
+          <a:xfrm>
+            <a:off x="2654066" y="-62873"/>
+            <a:ext cx="6321600" cy="635400"/>
+          </a:xfrm>
+          <a:prstGeom prst="rect">
+            <a:avLst/>
+          </a:prstGeom>
+        </p:spPr>
+        <p:txBody>
+          <a:bodyPr anchorCtr="0" anchor="t" bIns="91425" lIns="91425" spcFirstLastPara="1" rIns="91425" wrap="square" tIns="91425">
+            <a:noAutofit/>
+          </a:bodyPr>
+          <a:lstStyle/>
+          <a:p>
+            <a:pPr indent="0" lvl="0" marL="0" rtl="0" algn="ctr">
+              <a:spcBef>
+                <a:spcPts val="0"/>
+              </a:spcBef>
+              <a:spcAft>
+                <a:spcPts val="0"/>
+              </a:spcAft>
+              <a:buNone/>
+            </a:pPr>
+            <a:r>
+              <a:rPr lang="en"/>
+              <a:t>References</a:t>
+            </a:r>
+            <a:endParaRPr/>
+          </a:p>
+        </p:txBody>
+      </p:sp>
+      <p:sp>
+        <p:nvSpPr>
+          <p:cNvPr id="136" name="Google Shape;136;p21"/>
+          <p:cNvSpPr txBox="1"/>
+          <p:nvPr>
+            <p:ph idx="1" type="body"/>
+          </p:nvPr>
+        </p:nvSpPr>
+        <p:spPr>
+          <a:xfrm>
+            <a:off x="46175" y="554059"/>
+            <a:ext cx="9012600" cy="4257000"/>
+          </a:xfrm>
+          <a:prstGeom prst="rect">
+            <a:avLst/>
+          </a:prstGeom>
+        </p:spPr>
+        <p:txBody>
+          <a:bodyPr anchorCtr="0" anchor="t" bIns="91425" lIns="91425" spcFirstLastPara="1" rIns="91425" wrap="square" tIns="91425">
+            <a:noAutofit/>
+          </a:bodyPr>
+          <a:lstStyle/>
+          <a:p>
+            <a:pPr indent="-457200" lvl="0" marL="457200" rtl="0" algn="l">
+              <a:lnSpc>
+                <a:spcPct val="150000"/>
+              </a:lnSpc>
+              <a:spcBef>
+                <a:spcPts val="1200"/>
+              </a:spcBef>
+              <a:spcAft>
+                <a:spcPts val="0"/>
+              </a:spcAft>
+              <a:buClr>
+                <a:schemeClr val="dk2"/>
+              </a:buClr>
+              <a:buSzPts val="1100"/>
+              <a:buFont typeface="Arial"/>
+              <a:buNone/>
+            </a:pPr>
+            <a:r>
+              <a:rPr lang="en" sz="1200"/>
+              <a:t>Charters, D. A. (2007). 9/11: Seven years into history. </a:t>
+            </a:r>
+            <a:r>
+              <a:rPr i="1" lang="en" sz="1200"/>
+              <a:t>The Journal of Conflict Studies, 11</a:t>
+            </a:r>
+            <a:r>
+              <a:rPr lang="en" sz="1200"/>
+              <a:t>(1).</a:t>
+            </a:r>
+            <a:r>
+              <a:rPr lang="en" sz="1200">
+                <a:uFill>
+                  <a:noFill/>
+                </a:uFill>
+                <a:hlinkClick r:id="rId3"/>
+              </a:rPr>
+              <a:t> </a:t>
+            </a:r>
+            <a:r>
+              <a:rPr lang="en" sz="1200" u="sng">
+                <a:solidFill>
+                  <a:srgbClr val="1155CC"/>
+                </a:solidFill>
+                <a:hlinkClick r:id="rId4">
+                  <a:extLst>
+                    <a:ext uri="{A12FA001-AC4F-418D-AE19-62706E023703}">
+                      <ahyp:hlinkClr val="tx"/>
+                    </a:ext>
+                  </a:extLst>
+                </a:hlinkClick>
+              </a:rPr>
+              <a:t>https://journals.lib.unb.ca/index.php/JCS/article/view/10539/13299</a:t>
+            </a:r>
+            <a:endParaRPr sz="1200" u="sng">
+              <a:solidFill>
+                <a:srgbClr val="1155CC"/>
+              </a:solidFill>
+            </a:endParaRPr>
+          </a:p>
+          <a:p>
+            <a:pPr indent="-457200" lvl="0" marL="457200" rtl="0" algn="l">
+              <a:lnSpc>
+                <a:spcPct val="150000"/>
+              </a:lnSpc>
+              <a:spcBef>
+                <a:spcPts val="1200"/>
+              </a:spcBef>
+              <a:spcAft>
+                <a:spcPts val="0"/>
+              </a:spcAft>
+              <a:buClr>
+                <a:schemeClr val="dk2"/>
+              </a:buClr>
+              <a:buSzPts val="1100"/>
+              <a:buFont typeface="Arial"/>
+              <a:buNone/>
+            </a:pPr>
+            <a:r>
+              <a:rPr lang="en" sz="1200"/>
+              <a:t>DeRosa, A. (2011). Analyzing Literature after 9/11. MFS Modern Fiction Studies 57(3), 607-618. </a:t>
+            </a:r>
+            <a:r>
+              <a:rPr lang="en" sz="1200" u="sng">
+                <a:solidFill>
+                  <a:srgbClr val="1155CC"/>
+                </a:solidFill>
+                <a:hlinkClick r:id="rId5">
+                  <a:extLst>
+                    <a:ext uri="{A12FA001-AC4F-418D-AE19-62706E023703}">
+                      <ahyp:hlinkClr val="tx"/>
+                    </a:ext>
+                  </a:extLst>
+                </a:hlinkClick>
+              </a:rPr>
+              <a:t>https://dx.doi.org/10.1353/mfs.2011.0063.</a:t>
+            </a:r>
+            <a:endParaRPr sz="1200"/>
+          </a:p>
+          <a:p>
+            <a:pPr indent="-457200" lvl="0" marL="457200" rtl="0" algn="l">
+              <a:lnSpc>
+                <a:spcPct val="150000"/>
+              </a:lnSpc>
+              <a:spcBef>
+                <a:spcPts val="1200"/>
+              </a:spcBef>
+              <a:spcAft>
+                <a:spcPts val="0"/>
+              </a:spcAft>
+              <a:buClr>
+                <a:schemeClr val="dk2"/>
+              </a:buClr>
+              <a:buSzPts val="1100"/>
+              <a:buFont typeface="Arial"/>
+              <a:buNone/>
+            </a:pPr>
+            <a:r>
+              <a:rPr lang="en" sz="1200"/>
+              <a:t>Dudziak, M. L. (2012). </a:t>
+            </a:r>
+            <a:r>
+              <a:rPr i="1" lang="en" sz="1200"/>
+              <a:t>War time: An idea, its history, its consequences</a:t>
+            </a:r>
+            <a:r>
+              <a:rPr lang="en" sz="1200"/>
+              <a:t>. Oxford University Press.</a:t>
+            </a:r>
+            <a:endParaRPr sz="1200"/>
+          </a:p>
+          <a:p>
+            <a:pPr indent="-457200" lvl="0" marL="457200" rtl="0" algn="l">
+              <a:lnSpc>
+                <a:spcPct val="150000"/>
+              </a:lnSpc>
+              <a:spcBef>
+                <a:spcPts val="1200"/>
+              </a:spcBef>
+              <a:spcAft>
+                <a:spcPts val="0"/>
+              </a:spcAft>
+              <a:buClr>
+                <a:schemeClr val="dk2"/>
+              </a:buClr>
+              <a:buSzPts val="1100"/>
+              <a:buFont typeface="Arial"/>
+              <a:buNone/>
+            </a:pPr>
+            <a:r>
+              <a:rPr lang="en" sz="1200"/>
+              <a:t>Eikonsalo, S. (2025). Why do they hate us? The motives behind terrorism in Don DeLillo’s </a:t>
+            </a:r>
+            <a:r>
+              <a:rPr i="1" lang="en" sz="1200"/>
+              <a:t>Falling Man</a:t>
+            </a:r>
+            <a:r>
+              <a:rPr lang="en" sz="1200"/>
+              <a:t> and John Updike’s </a:t>
+            </a:r>
+            <a:r>
+              <a:rPr i="1" lang="en" sz="1200"/>
+              <a:t>Terrorist</a:t>
+            </a:r>
+            <a:r>
+              <a:rPr lang="en" sz="1200"/>
+              <a:t>. </a:t>
+            </a:r>
+            <a:r>
+              <a:rPr i="1" lang="en" sz="1200"/>
+              <a:t>University of Bucharest Review. Literary and Cultural Studies Series, 15</a:t>
+            </a:r>
+            <a:r>
+              <a:rPr lang="en" sz="1200"/>
+              <a:t>(1), 16–28.</a:t>
+            </a:r>
+            <a:r>
+              <a:rPr lang="en" sz="1200">
+                <a:uFill>
+                  <a:noFill/>
+                </a:uFill>
+                <a:hlinkClick r:id="rId6"/>
+              </a:rPr>
+              <a:t> </a:t>
+            </a:r>
+            <a:r>
+              <a:rPr lang="en" sz="1200" u="sng">
+                <a:solidFill>
+                  <a:srgbClr val="1155CC"/>
+                </a:solidFill>
+                <a:hlinkClick r:id="rId7">
+                  <a:extLst>
+                    <a:ext uri="{A12FA001-AC4F-418D-AE19-62706E023703}">
+                      <ahyp:hlinkClr val="tx"/>
+                    </a:ext>
+                  </a:extLst>
+                </a:hlinkClick>
+              </a:rPr>
+              <a:t>https://doi.org/10.31178/UBR.15.1.2</a:t>
+            </a:r>
+            <a:endParaRPr sz="1200" u="sng">
+              <a:solidFill>
+                <a:srgbClr val="1155CC"/>
+              </a:solidFill>
+            </a:endParaRPr>
+          </a:p>
+          <a:p>
+            <a:pPr indent="-457200" lvl="0" marL="457200" rtl="0" algn="l">
+              <a:lnSpc>
+                <a:spcPct val="150000"/>
+              </a:lnSpc>
+              <a:spcBef>
+                <a:spcPts val="1200"/>
+              </a:spcBef>
+              <a:spcAft>
+                <a:spcPts val="0"/>
+              </a:spcAft>
+              <a:buClr>
+                <a:schemeClr val="dk2"/>
+              </a:buClr>
+              <a:buSzPts val="1100"/>
+              <a:buFont typeface="Arial"/>
+              <a:buNone/>
+            </a:pPr>
+            <a:r>
+              <a:rPr lang="en" sz="1200"/>
+              <a:t>Jones, D. M., &amp; Smith, M. L. R. (2021). The age of ambiguity: Art and the war on terror twenty years after 9/11. </a:t>
+            </a:r>
+            <a:r>
+              <a:rPr i="1" lang="en" sz="1200"/>
+              <a:t>Studies in Conflict &amp; Terrorism, 47</a:t>
+            </a:r>
+            <a:r>
+              <a:rPr lang="en" sz="1200"/>
+              <a:t>, 115–134.</a:t>
+            </a:r>
+            <a:r>
+              <a:rPr lang="en" sz="1200">
+                <a:uFill>
+                  <a:noFill/>
+                </a:uFill>
+                <a:hlinkClick r:id="rId8"/>
+              </a:rPr>
+              <a:t> </a:t>
+            </a:r>
+            <a:r>
+              <a:rPr lang="en" sz="1200" u="sng">
+                <a:solidFill>
+                  <a:srgbClr val="1155CC"/>
+                </a:solidFill>
+                <a:hlinkClick r:id="rId9">
+                  <a:extLst>
+                    <a:ext uri="{A12FA001-AC4F-418D-AE19-62706E023703}">
+                      <ahyp:hlinkClr val="tx"/>
+                    </a:ext>
+                  </a:extLst>
+                </a:hlinkClick>
+              </a:rPr>
+              <a:t>https://doi.org/10.1080/1057610X.2021.1943813</a:t>
+            </a:r>
+            <a:endParaRPr sz="1200" u="sng">
+              <a:solidFill>
+                <a:srgbClr val="1155CC"/>
+              </a:solidFill>
+            </a:endParaRPr>
+          </a:p>
+          <a:p>
+            <a:pPr indent="-457200" lvl="0" marL="457200" rtl="0" algn="l">
+              <a:lnSpc>
+                <a:spcPct val="150000"/>
+              </a:lnSpc>
+              <a:spcBef>
+                <a:spcPts val="1200"/>
+              </a:spcBef>
+              <a:spcAft>
+                <a:spcPts val="0"/>
+              </a:spcAft>
+              <a:buClr>
+                <a:schemeClr val="dk2"/>
+              </a:buClr>
+              <a:buSzPts val="1100"/>
+              <a:buFont typeface="Arial"/>
+              <a:buNone/>
+            </a:pPr>
+            <a:r>
+              <a:rPr lang="en" sz="1200"/>
+              <a:t>Morgan, M. J. (Ed.). (2009). </a:t>
+            </a:r>
+            <a:r>
+              <a:rPr i="1" lang="en" sz="1200"/>
+              <a:t>The impact of 9/11 on religion and philosophy: The day that changed everything?</a:t>
+            </a:r>
+            <a:r>
+              <a:rPr lang="en" sz="1200"/>
+              <a:t> Palgrave Macmillan.</a:t>
+            </a:r>
+            <a:endParaRPr sz="1200"/>
+          </a:p>
+          <a:p>
+            <a:pPr indent="-457200" lvl="0" marL="457200" rtl="0" algn="l">
+              <a:lnSpc>
+                <a:spcPct val="150000"/>
+              </a:lnSpc>
+              <a:spcBef>
+                <a:spcPts val="1200"/>
+              </a:spcBef>
+              <a:spcAft>
+                <a:spcPts val="1200"/>
+              </a:spcAft>
+              <a:buNone/>
+            </a:pPr>
+            <a:r>
+              <a:rPr lang="en" sz="1200"/>
+              <a:t>Rockmore, T. (2011). </a:t>
+            </a:r>
+            <a:r>
+              <a:rPr i="1" lang="en" sz="1200"/>
+              <a:t>Before and after 9/11: A philosophical examination of globalization, terror, and history</a:t>
+            </a:r>
+            <a:r>
+              <a:rPr lang="en" sz="1200"/>
+              <a:t>. Continuum.</a:t>
+            </a:r>
+            <a:endParaRPr/>
+          </a:p>
+        </p:txBody>
+      </p:sp>
+    </p:spTree>
+  </p:cSld>
+  <p:clrMapOvr>
+    <a:masterClrMapping/>
+  </p:clrMapOvr>
+</p:sld>
+</file>
+
 <file path=ppt/theme/theme1.xml><?xml version="1.0" encoding="utf-8"?>
+<a:theme xmlns:a="http://schemas.openxmlformats.org/drawingml/2006/main" xmlns:r="http://schemas.openxmlformats.org/officeDocument/2006/relationships" name="Swiss">
+  <a:themeElements>
+    <a:clrScheme name="Swiss">
+      <a:dk1>
+        <a:srgbClr val="F46524"/>
+      </a:dk1>
+      <a:lt1>
+        <a:srgbClr val="FFFFFF"/>
+      </a:lt1>
+      <a:dk2>
+        <a:srgbClr val="000000"/>
+      </a:dk2>
+      <a:lt2>
+        <a:srgbClr val="757575"/>
+      </a:lt2>
+      <a:accent1>
+        <a:srgbClr val="01579B"/>
+      </a:accent1>
+      <a:accent2>
+        <a:srgbClr val="27C7BD"/>
+      </a:accent2>
+      <a:accent3>
+        <a:srgbClr val="0099E8"/>
+      </a:accent3>
+      <a:accent4>
+        <a:srgbClr val="51B9A3"/>
+      </a:accent4>
+      <a:accent5>
+        <a:srgbClr val="FB8C00"/>
+      </a:accent5>
+      <a:accent6>
+        <a:srgbClr val="FFAE88"/>
+      </a:accent6>
+      <a:hlink>
+        <a:srgbClr val="0277BD"/>
+      </a:hlink>
+      <a:folHlink>
+        <a:srgbClr val="0277BD"/>
+      </a:folHlink>
+    </a:clrScheme>
+    <a:fontScheme name="Office">
+      <a:majorFont>
+        <a:latin typeface="Arial"/>
+        <a:ea typeface=""/>
+        <a:cs typeface=""/>
+        <a:font script="Jpan" typeface="ＭＳ Ｐゴシック"/>
+        <a:font script="Hang" typeface="맑은 고딕"/>
+        <a:font script="Hans" typeface="宋体"/>
+        <a:font script="Hant" typeface="新細明體"/>
+        <a:font script="Arab" typeface="Times New Roman"/>
+        <a:font script="Hebr" typeface="Times New Roman"/>
+        <a:font script="Thai" typeface="Angsana New"/>
+        <a:font script="Ethi" typeface="Nyala"/>
+        <a:font script="Beng" typeface="Vrinda"/>
+        <a:font script="Gujr" typeface="Shruti"/>
+        <a:font script="Khmr" typeface="MoolBoran"/>
+        <a:font script="Knda" typeface="Tunga"/>
+        <a:font script="Guru" typeface="Raavi"/>
+        <a:font script="Cans" typeface="Euphemia"/>
+        <a:font script="Cher" typeface="Plantagenet Cherokee"/>
+        <a:font script="Yiii" typeface="Microsoft Yi Baiti"/>
+        <a:font script="Tibt" typeface="Microsoft Himalaya"/>
+        <a:font script="Thaa" typeface="MV Boli"/>
+        <a:font script="Deva" typeface="Mangal"/>
+        <a:font script="Telu" typeface="Gautami"/>
+        <a:font script="Taml" typeface="Latha"/>
+        <a:font script="Syrc" typeface="Estrangelo Edessa"/>
+        <a:font script="Orya" typeface="Kalinga"/>
+        <a:font script="Mlym" typeface="Kartika"/>
+        <a:font script="Laoo" typeface="DokChampa"/>
+        <a:font script="Sinh" typeface="Iskoola Pota"/>
+        <a:font script="Mong" typeface="Mongolian Baiti"/>
+        <a:font script="Viet" typeface="Times New Roman"/>
+        <a:font script="Uigh" typeface="Microsoft Uighur"/>
+        <a:font script="Geor" typeface="Sylfaen"/>
+      </a:majorFont>
+      <a:minorFont>
+        <a:latin typeface="Arial"/>
+        <a:ea typeface=""/>
+        <a:cs typeface=""/>
+        <a:font script="Jpan" typeface="ＭＳ Ｐゴシック"/>
+        <a:font script="Hang" typeface="맑은 고딕"/>
+        <a:font script="Hans" typeface="宋体"/>
+        <a:font script="Hant" typeface="新細明體"/>
+        <a:font script="Arab" typeface="Arial"/>
+        <a:font script="Hebr" typeface="Arial"/>
+        <a:font script="Thai" typeface="Cordia New"/>
+        <a:font script="Ethi" typeface="Nyala"/>
+        <a:font script="Beng" typeface="Vrinda"/>
+        <a:font script="Gujr" typeface="Shruti"/>
+        <a:font script="Khmr" typeface="DaunPenh"/>
+        <a:font script="Knda" typeface="Tunga"/>
+        <a:font script="Guru" typeface="Raavi"/>
+        <a:font script="Cans" typeface="Euphemia"/>
+        <a:font script="Cher" typeface="Plantagenet Cherokee"/>
+        <a:font script="Yiii" typeface="Microsoft Yi Baiti"/>
+        <a:font script="Tibt" typeface="Microsoft Himalaya"/>
+        <a:font script="Thaa" typeface="MV Boli"/>
+        <a:font script="Deva" typeface="Mangal"/>
+        <a:font script="Telu" typeface="Gautami"/>
+        <a:font script="Taml" typeface="Latha"/>
+        <a:font script="Syrc" typeface="Estrangelo Edessa"/>
+        <a:font script="Orya" typeface="Kalinga"/>
+        <a:font script="Mlym" typeface="Kartika"/>
+        <a:font script="Laoo" typeface="DokChampa"/>
+        <a:font script="Sinh" typeface="Iskoola Pota"/>
+        <a:font script="Mong" typeface="Mongolian Baiti"/>
+        <a:font script="Viet" typeface="Arial"/>
+        <a:font script="Uigh" typeface="Microsoft Uighur"/>
+        <a:font script="Geor" typeface="Sylfaen"/>
+      </a:minorFont>
+    </a:fontScheme>
+    <a:fmtScheme name="Office">
+      <a:fillStyleLst>
+        <a:solidFill>
+          <a:schemeClr val="phClr"/>
+        </a:solidFill>
+        <a:gradFill rotWithShape="1">
+          <a:gsLst>
+            <a:gs pos="0">
+              <a:schemeClr val="phClr">
+                <a:tint val="50000"/>
+                <a:satMod val="300000"/>
+              </a:schemeClr>
+            </a:gs>
+            <a:gs pos="35000">
+              <a:schemeClr val="phClr">
+                <a:tint val="37000"/>
+                <a:satMod val="300000"/>
+              </a:schemeClr>
+            </a:gs>
+            <a:gs pos="100000">
+              <a:schemeClr val="phClr">
+                <a:tint val="15000"/>
+                <a:satMod val="350000"/>
+              </a:schemeClr>
+            </a:gs>
+          </a:gsLst>
+          <a:lin ang="16200000" scaled="1"/>
+        </a:gradFill>
+        <a:gradFill rotWithShape="1">
+          <a:gsLst>
+            <a:gs pos="0">
+              <a:schemeClr val="phClr">
+                <a:tint val="100000"/>
+                <a:shade val="100000"/>
+                <a:satMod val="130000"/>
+              </a:schemeClr>
+            </a:gs>
+            <a:gs pos="100000">
+              <a:schemeClr val="phClr">
+                <a:tint val="50000"/>
+                <a:shade val="100000"/>
+                <a:satMod val="350000"/>
+              </a:schemeClr>
+            </a:gs>
+          </a:gsLst>
+          <a:lin ang="16200000" scaled="0"/>
+        </a:gradFill>
+      </a:fillStyleLst>
+      <a:lnStyleLst>
+        <a:ln w="9525" cap="flat" cmpd="sng" algn="ctr">
+          <a:solidFill>
+            <a:schemeClr val="phClr">
+              <a:shade val="95000"/>
+              <a:satMod val="105000"/>
+            </a:schemeClr>
+          </a:solidFill>
+          <a:prstDash val="solid"/>
+        </a:ln>
+        <a:ln w="25400" cap="flat" cmpd="sng" algn="ctr">
+          <a:solidFill>
+            <a:schemeClr val="phClr"/>
+          </a:solidFill>
+          <a:prstDash val="solid"/>
+        </a:ln>
+        <a:ln w="38100" cap="flat" cmpd="sng" algn="ctr">
+          <a:solidFill>
+            <a:schemeClr val="phClr"/>
+          </a:solidFill>
+          <a:prstDash val="solid"/>
+        </a:ln>
+      </a:lnStyleLst>
+      <a:effectStyleLst>
+        <a:effectStyle>
+          <a:effectLst>
+            <a:outerShdw blurRad="40000" dist="20000" dir="5400000" rotWithShape="0">
+              <a:srgbClr val="000000">
+                <a:alpha val="38000"/>
+              </a:srgbClr>
+            </a:outerShdw>
+          </a:effectLst>
+        </a:effectStyle>
+        <a:effectStyle>
+          <a:effectLst>
+            <a:outerShdw blurRad="40000" dist="23000" dir="5400000" rotWithShape="0">
+              <a:srgbClr val="000000">
+                <a:alpha val="35000"/>
+              </a:srgbClr>
+            </a:outerShdw>
+          </a:effectLst>
+        </a:effectStyle>
+        <a:effectStyle>
+          <a:effectLst>
+            <a:outerShdw blurRad="40000" dist="23000" dir="5400000" rotWithShape="0">
+              <a:srgbClr val="000000">
+                <a:alpha val="35000"/>
+              </a:srgbClr>
+            </a:outerShdw>
+          </a:effectLst>
+          <a:scene3d>
+            <a:camera prst="orthographicFront">
+              <a:rot lat="0" lon="0" rev="0"/>
+            </a:camera>
+            <a:lightRig rig="threePt" dir="t">
+              <a:rot lat="0" lon="0" rev="1200000"/>
+            </a:lightRig>
+          </a:scene3d>
+          <a:sp3d>
+            <a:bevelT w="63500" h="25400"/>
+          </a:sp3d>
+        </a:effectStyle>
+      </a:effectStyleLst>
+      <a:bgFillStyleLst>
+        <a:solidFill>
+          <a:schemeClr val="phClr"/>
+        </a:solidFill>
+        <a:gradFill rotWithShape="1">
+          <a:gsLst>
+            <a:gs pos="0">
+              <a:schemeClr val="phClr">
+                <a:tint val="40000"/>
+                <a:satMod val="350000"/>
+              </a:schemeClr>
+            </a:gs>
+            <a:gs pos="40000">
+              <a:schemeClr val="phClr">
+                <a:tint val="45000"/>
+                <a:shade val="99000"/>
+                <a:satMod val="350000"/>
+              </a:schemeClr>
+            </a:gs>
+            <a:gs pos="100000">
+              <a:schemeClr val="phClr">
+                <a:shade val="20000"/>
+                <a:satMod val="255000"/>
+              </a:schemeClr>
+            </a:gs>
+          </a:gsLst>
+          <a:path path="circle">
+            <a:fillToRect l="50000" t="-80000" r="50000" b="180000"/>
+          </a:path>
+        </a:gradFill>
+        <a:gradFill rotWithShape="1">
+          <a:gsLst>
+            <a:gs pos="0">
+              <a:schemeClr val="phClr">
+                <a:tint val="80000"/>
+                <a:satMod val="300000"/>
+              </a:schemeClr>
+            </a:gs>
+            <a:gs pos="100000">
+              <a:schemeClr val="phClr">
+                <a:shade val="30000"/>
+                <a:satMod val="200000"/>
+              </a:schemeClr>
+            </a:gs>
+          </a:gsLst>
+          <a:path path="circle">
+            <a:fillToRect l="50000" t="50000" r="50000" b="50000"/>
+          </a:path>
+        </a:gradFill>
+      </a:bgFillStyleLst>
+    </a:fmtScheme>
+  </a:themeElements>
+</a:theme>
+</file>
+
+<file path=ppt/theme/theme2.xml><?xml version="1.0" encoding="utf-8"?>
 <a:theme xmlns:a="http://schemas.openxmlformats.org/drawingml/2006/main" xmlns:r="http://schemas.openxmlformats.org/officeDocument/2006/relationships">
   <a:themeElements>
     <a:clrScheme name="Default">
@@ -10677,283 +11471,4 @@
     </a:fmtScheme>
   </a:themeElements>
 </a:theme>
-</file>
-
-<file path=ppt/theme/theme2.xml><?xml version="1.0" encoding="utf-8"?>
-<a:theme xmlns:a="http://schemas.openxmlformats.org/drawingml/2006/main" xmlns:r="http://schemas.openxmlformats.org/officeDocument/2006/relationships" name="Swiss">
-  <a:themeElements>
-    <a:clrScheme name="Swiss">
-      <a:dk1>
-        <a:srgbClr val="F46524"/>
-      </a:dk1>
-      <a:lt1>
-        <a:srgbClr val="FFFFFF"/>
-      </a:lt1>
-      <a:dk2>
-        <a:srgbClr val="000000"/>
-      </a:dk2>
-      <a:lt2>
-        <a:srgbClr val="757575"/>
-      </a:lt2>
-      <a:accent1>
-        <a:srgbClr val="01579B"/>
-      </a:accent1>
-      <a:accent2>
-        <a:srgbClr val="27C7BD"/>
-      </a:accent2>
-      <a:accent3>
-        <a:srgbClr val="0099E8"/>
-      </a:accent3>
-      <a:accent4>
-        <a:srgbClr val="51B9A3"/>
-      </a:accent4>
-      <a:accent5>
-        <a:srgbClr val="FB8C00"/>
-      </a:accent5>
-      <a:accent6>
-        <a:srgbClr val="FFAE88"/>
-      </a:accent6>
-      <a:hlink>
-        <a:srgbClr val="0277BD"/>
-      </a:hlink>
-      <a:folHlink>
-        <a:srgbClr val="0277BD"/>
-      </a:folHlink>
-    </a:clrScheme>
-    <a:fontScheme name="Office">
-      <a:majorFont>
-        <a:latin typeface="Arial"/>
-        <a:ea typeface=""/>
-        <a:cs typeface=""/>
-        <a:font script="Jpan" typeface="ＭＳ Ｐゴシック"/>
-        <a:font script="Hang" typeface="맑은 고딕"/>
-        <a:font script="Hans" typeface="宋体"/>
-        <a:font script="Hant" typeface="新細明體"/>
-        <a:font script="Arab" typeface="Times New Roman"/>
-        <a:font script="Hebr" typeface="Times New Roman"/>
-        <a:font script="Thai" typeface="Angsana New"/>
-        <a:font script="Ethi" typeface="Nyala"/>
-        <a:font script="Beng" typeface="Vrinda"/>
-        <a:font script="Gujr" typeface="Shruti"/>
-        <a:font script="Khmr" typeface="MoolBoran"/>
-        <a:font script="Knda" typeface="Tunga"/>
-        <a:font script="Guru" typeface="Raavi"/>
-        <a:font script="Cans" typeface="Euphemia"/>
-        <a:font script="Cher" typeface="Plantagenet Cherokee"/>
-        <a:font script="Yiii" typeface="Microsoft Yi Baiti"/>
-        <a:font script="Tibt" typeface="Microsoft Himalaya"/>
-        <a:font script="Thaa" typeface="MV Boli"/>
-        <a:font script="Deva" typeface="Mangal"/>
-        <a:font script="Telu" typeface="Gautami"/>
-        <a:font script="Taml" typeface="Latha"/>
-        <a:font script="Syrc" typeface="Estrangelo Edessa"/>
-        <a:font script="Orya" typeface="Kalinga"/>
-        <a:font script="Mlym" typeface="Kartika"/>
-        <a:font script="Laoo" typeface="DokChampa"/>
-        <a:font script="Sinh" typeface="Iskoola Pota"/>
-        <a:font script="Mong" typeface="Mongolian Baiti"/>
-        <a:font script="Viet" typeface="Times New Roman"/>
-        <a:font script="Uigh" typeface="Microsoft Uighur"/>
-        <a:font script="Geor" typeface="Sylfaen"/>
-      </a:majorFont>
-      <a:minorFont>
-        <a:latin typeface="Arial"/>
-        <a:ea typeface=""/>
-        <a:cs typeface=""/>
-        <a:font script="Jpan" typeface="ＭＳ Ｐゴシック"/>
-        <a:font script="Hang" typeface="맑은 고딕"/>
-        <a:font script="Hans" typeface="宋体"/>
-        <a:font script="Hant" typeface="新細明體"/>
-        <a:font script="Arab" typeface="Arial"/>
-        <a:font script="Hebr" typeface="Arial"/>
-        <a:font script="Thai" typeface="Cordia New"/>
-        <a:font script="Ethi" typeface="Nyala"/>
-        <a:font script="Beng" typeface="Vrinda"/>
-        <a:font script="Gujr" typeface="Shruti"/>
-        <a:font script="Khmr" typeface="DaunPenh"/>
-        <a:font script="Knda" typeface="Tunga"/>
-        <a:font script="Guru" typeface="Raavi"/>
-        <a:font script="Cans" typeface="Euphemia"/>
-        <a:font script="Cher" typeface="Plantagenet Cherokee"/>
-        <a:font script="Yiii" typeface="Microsoft Yi Baiti"/>
-        <a:font script="Tibt" typeface="Microsoft Himalaya"/>
-        <a:font script="Thaa" typeface="MV Boli"/>
-        <a:font script="Deva" typeface="Mangal"/>
-        <a:font script="Telu" typeface="Gautami"/>
-        <a:font script="Taml" typeface="Latha"/>
-        <a:font script="Syrc" typeface="Estrangelo Edessa"/>
-        <a:font script="Orya" typeface="Kalinga"/>
-        <a:font script="Mlym" typeface="Kartika"/>
-        <a:font script="Laoo" typeface="DokChampa"/>
-        <a:font script="Sinh" typeface="Iskoola Pota"/>
-        <a:font script="Mong" typeface="Mongolian Baiti"/>
-        <a:font script="Viet" typeface="Arial"/>
-        <a:font script="Uigh" typeface="Microsoft Uighur"/>
-        <a:font script="Geor" typeface="Sylfaen"/>
-      </a:minorFont>
-    </a:fontScheme>
-    <a:fmtScheme name="Office">
-      <a:fillStyleLst>
-        <a:solidFill>
-          <a:schemeClr val="phClr"/>
-        </a:solidFill>
-        <a:gradFill rotWithShape="1">
-          <a:gsLst>
-            <a:gs pos="0">
-              <a:schemeClr val="phClr">
-                <a:tint val="50000"/>
-                <a:satMod val="300000"/>
-              </a:schemeClr>
-            </a:gs>
-            <a:gs pos="35000">
-              <a:schemeClr val="phClr">
-                <a:tint val="37000"/>
-                <a:satMod val="300000"/>
-              </a:schemeClr>
-            </a:gs>
-            <a:gs pos="100000">
-              <a:schemeClr val="phClr">
-                <a:tint val="15000"/>
-                <a:satMod val="350000"/>
-              </a:schemeClr>
-            </a:gs>
-          </a:gsLst>
-          <a:lin ang="16200000" scaled="1"/>
-        </a:gradFill>
-        <a:gradFill rotWithShape="1">
-          <a:gsLst>
-            <a:gs pos="0">
-              <a:schemeClr val="phClr">
-                <a:tint val="100000"/>
-                <a:shade val="100000"/>
-                <a:satMod val="130000"/>
-              </a:schemeClr>
-            </a:gs>
-            <a:gs pos="100000">
-              <a:schemeClr val="phClr">
-                <a:tint val="50000"/>
-                <a:shade val="100000"/>
-                <a:satMod val="350000"/>
-              </a:schemeClr>
-            </a:gs>
-          </a:gsLst>
-          <a:lin ang="16200000" scaled="0"/>
-        </a:gradFill>
-      </a:fillStyleLst>
-      <a:lnStyleLst>
-        <a:ln w="9525" cap="flat" cmpd="sng" algn="ctr">
-          <a:solidFill>
-            <a:schemeClr val="phClr">
-              <a:shade val="95000"/>
-              <a:satMod val="105000"/>
-            </a:schemeClr>
-          </a:solidFill>
-          <a:prstDash val="solid"/>
-        </a:ln>
-        <a:ln w="25400" cap="flat" cmpd="sng" algn="ctr">
-          <a:solidFill>
-            <a:schemeClr val="phClr"/>
-          </a:solidFill>
-          <a:prstDash val="solid"/>
-        </a:ln>
-        <a:ln w="38100" cap="flat" cmpd="sng" algn="ctr">
-          <a:solidFill>
-            <a:schemeClr val="phClr"/>
-          </a:solidFill>
-          <a:prstDash val="solid"/>
-        </a:ln>
-      </a:lnStyleLst>
-      <a:effectStyleLst>
-        <a:effectStyle>
-          <a:effectLst>
-            <a:outerShdw blurRad="40000" dist="20000" dir="5400000" rotWithShape="0">
-              <a:srgbClr val="000000">
-                <a:alpha val="38000"/>
-              </a:srgbClr>
-            </a:outerShdw>
-          </a:effectLst>
-        </a:effectStyle>
-        <a:effectStyle>
-          <a:effectLst>
-            <a:outerShdw blurRad="40000" dist="23000" dir="5400000" rotWithShape="0">
-              <a:srgbClr val="000000">
-                <a:alpha val="35000"/>
-              </a:srgbClr>
-            </a:outerShdw>
-          </a:effectLst>
-        </a:effectStyle>
-        <a:effectStyle>
-          <a:effectLst>
-            <a:outerShdw blurRad="40000" dist="23000" dir="5400000" rotWithShape="0">
-              <a:srgbClr val="000000">
-                <a:alpha val="35000"/>
-              </a:srgbClr>
-            </a:outerShdw>
-          </a:effectLst>
-          <a:scene3d>
-            <a:camera prst="orthographicFront">
-              <a:rot lat="0" lon="0" rev="0"/>
-            </a:camera>
-            <a:lightRig rig="threePt" dir="t">
-              <a:rot lat="0" lon="0" rev="1200000"/>
-            </a:lightRig>
-          </a:scene3d>
-          <a:sp3d>
-            <a:bevelT w="63500" h="25400"/>
-          </a:sp3d>
-        </a:effectStyle>
-      </a:effectStyleLst>
-      <a:bgFillStyleLst>
-        <a:solidFill>
-          <a:schemeClr val="phClr"/>
-        </a:solidFill>
-        <a:gradFill rotWithShape="1">
-          <a:gsLst>
-            <a:gs pos="0">
-              <a:schemeClr val="phClr">
-                <a:tint val="40000"/>
-                <a:satMod val="350000"/>
-              </a:schemeClr>
-            </a:gs>
-            <a:gs pos="40000">
-              <a:schemeClr val="phClr">
-                <a:tint val="45000"/>
-                <a:shade val="99000"/>
-                <a:satMod val="350000"/>
-              </a:schemeClr>
-            </a:gs>
-            <a:gs pos="100000">
-              <a:schemeClr val="phClr">
-                <a:shade val="20000"/>
-                <a:satMod val="255000"/>
-              </a:schemeClr>
-            </a:gs>
-          </a:gsLst>
-          <a:path path="circle">
-            <a:fillToRect l="50000" t="-80000" r="50000" b="180000"/>
-          </a:path>
-        </a:gradFill>
-        <a:gradFill rotWithShape="1">
-          <a:gsLst>
-            <a:gs pos="0">
-              <a:schemeClr val="phClr">
-                <a:tint val="80000"/>
-                <a:satMod val="300000"/>
-              </a:schemeClr>
-            </a:gs>
-            <a:gs pos="100000">
-              <a:schemeClr val="phClr">
-                <a:shade val="30000"/>
-                <a:satMod val="200000"/>
-              </a:schemeClr>
-            </a:gs>
-          </a:gsLst>
-          <a:path path="circle">
-            <a:fillToRect l="50000" t="50000" r="50000" b="50000"/>
-          </a:path>
-        </a:gradFill>
-      </a:bgFillStyleLst>
-    </a:fmtScheme>
-  </a:themeElements>
-</a:theme>
 </file>
</xml_diff>